<commit_message>
Aligerar el contenido de las diapositivas
Las franjas oscuras eran párrafos largos donde debían ser datos de un
vistazo:

- Reconocimiento jurídico: el párrafo sobre cinco países pasa a cuatro
  columnas de país y estado.
- Deber de información previa: el párrafo pasa a un dato destacado
  (20 días) más una línea.
- Partes involucradas: las dos franjas quedan en una línea cada una.

También se recortan las listas de derechos y obligaciones a tres ítems,
se acortan las glosas de ventajas y desventajas y se sube el cuerpo a
10,5 pt para que las tarjetas llenen sin dejar hueco muerto.
</commit_message>
<xml_diff>
--- a/Contrato de Franquicia - Grupo 1.pptx
+++ b/Contrato de Franquicia - Grupo 1.pptx
@@ -5557,7 +5557,7 @@
         <p:spPr>
           <a:xfrm>
             <a:off x="6576044" y="3547872"/>
-            <a:ext cx="4418060" cy="1225296"/>
+            <a:ext cx="4418060" cy="1005840"/>
           </a:xfrm>
           <a:prstGeom prst="rect">
             <a:avLst/>
@@ -5597,37 +5597,6 @@
                 </a:solidFill>
                 <a:latin typeface="Calibri"/>
               </a:rPr>
-              <a:t>Bilateral y oneroso: obligaciones recíprocas y precio</a:t>
-            </a:r>
-          </a:p>
-          <a:p>
-            <a:pPr algn="l">
-              <a:lnSpc>
-                <a:spcPct val="120000"/>
-              </a:lnSpc>
-              <a:spcBef>
-                <a:spcPts val="0"/>
-              </a:spcBef>
-              <a:spcAft>
-                <a:spcPts val="500"/>
-              </a:spcAft>
-            </a:pPr>
-            <a:r>
-              <a:rPr sz="1000" b="1" i="0">
-                <a:solidFill>
-                  <a:srgbClr val="C56C3E"/>
-                </a:solidFill>
-                <a:latin typeface="Calibri"/>
-              </a:rPr>
-              <a:t>—  </a:t>
-            </a:r>
-            <a:r>
-              <a:rPr sz="1000" b="0" i="0">
-                <a:solidFill>
-                  <a:srgbClr val="445570"/>
-                </a:solidFill>
-                <a:latin typeface="Calibri"/>
-              </a:rPr>
               <a:t>De colaboración, no de simple intercambio</a:t>
             </a:r>
           </a:p>
@@ -5779,8 +5748,8 @@
         </p:nvSpPr>
         <p:spPr>
           <a:xfrm>
-            <a:off x="868680" y="5285232"/>
-            <a:ext cx="10454609" cy="786384"/>
+            <a:off x="868680" y="5230368"/>
+            <a:ext cx="10454609" cy="914400"/>
           </a:xfrm>
           <a:prstGeom prst="rect">
             <a:avLst/>
@@ -5823,8 +5792,8 @@
         </p:nvSpPr>
         <p:spPr>
           <a:xfrm>
-            <a:off x="1234440" y="5431536"/>
-            <a:ext cx="9723089" cy="201168"/>
+            <a:off x="1234440" y="5394960"/>
+            <a:ext cx="9723089" cy="182880"/>
           </a:xfrm>
           <a:prstGeom prst="rect">
             <a:avLst/>
@@ -5868,8 +5837,8 @@
         </p:nvSpPr>
         <p:spPr>
           <a:xfrm>
-            <a:off x="1234440" y="5650992"/>
-            <a:ext cx="9723089" cy="384048"/>
+            <a:off x="1234440" y="5632704"/>
+            <a:ext cx="2225032" cy="182880"/>
           </a:xfrm>
           <a:prstGeom prst="rect">
             <a:avLst/>
@@ -5884,23 +5853,338 @@
           <a:p>
             <a:pPr algn="l">
               <a:lnSpc>
-                <a:spcPct val="130000"/>
-              </a:lnSpc>
-              <a:spcBef>
-                <a:spcPts val="0"/>
-              </a:spcBef>
-              <a:spcAft>
-                <a:spcPts val="0"/>
-              </a:spcAft>
-            </a:pPr>
-            <a:r>
-              <a:rPr sz="1000" b="0" i="0">
+                <a:spcPct val="100000"/>
+              </a:lnSpc>
+              <a:spcBef>
+                <a:spcPts val="0"/>
+              </a:spcBef>
+              <a:spcAft>
+                <a:spcPts val="0"/>
+              </a:spcAft>
+            </a:pPr>
+            <a:r>
+              <a:rPr sz="1000" b="1" i="0">
                 <a:solidFill>
                   <a:srgbClr val="F3F1EC"/>
                 </a:solidFill>
                 <a:latin typeface="Calibri"/>
               </a:rPr>
-              <a:t>Argentina lo tipificó (arts. 1512–1524 CCyC); España lo regula por vía sectorial (Ley 7/1996); Ecuador lo reconoce en su Código de Comercio; Colombia y Perú lo mantienen como contrato atípico, de modo que el peso recae en la redacción del contrato y en la autonomía de la voluntad.</a:t>
+              <a:t>Argentina</a:t>
+            </a:r>
+          </a:p>
+        </p:txBody>
+      </p:sp>
+      <p:sp>
+        <p:nvSpPr>
+          <p:cNvPr id="27" name="TextBox 26"/>
+          <p:cNvSpPr txBox="1"/>
+          <p:nvPr/>
+        </p:nvSpPr>
+        <p:spPr>
+          <a:xfrm>
+            <a:off x="1234440" y="5833872"/>
+            <a:ext cx="2225032" cy="182880"/>
+          </a:xfrm>
+          <a:prstGeom prst="rect">
+            <a:avLst/>
+          </a:prstGeom>
+          <a:noFill/>
+        </p:spPr>
+        <p:txBody>
+          <a:bodyPr wrap="square" anchor="t" lIns="0" rIns="0" tIns="0" bIns="0">
+            <a:spAutoFit/>
+          </a:bodyPr>
+          <a:lstStyle/>
+          <a:p>
+            <a:pPr algn="l">
+              <a:lnSpc>
+                <a:spcPct val="100000"/>
+              </a:lnSpc>
+              <a:spcBef>
+                <a:spcPts val="0"/>
+              </a:spcBef>
+              <a:spcAft>
+                <a:spcPts val="0"/>
+              </a:spcAft>
+            </a:pPr>
+            <a:r>
+              <a:rPr sz="900" b="0" i="0">
+                <a:solidFill>
+                  <a:srgbClr val="A9B4C6"/>
+                </a:solidFill>
+                <a:latin typeface="Calibri"/>
+              </a:rPr>
+              <a:t>Tipificado (arts. 1512–1524)</a:t>
+            </a:r>
+          </a:p>
+        </p:txBody>
+      </p:sp>
+      <p:sp>
+        <p:nvSpPr>
+          <p:cNvPr id="28" name="TextBox 27"/>
+          <p:cNvSpPr txBox="1"/>
+          <p:nvPr/>
+        </p:nvSpPr>
+        <p:spPr>
+          <a:xfrm>
+            <a:off x="3733792" y="5632704"/>
+            <a:ext cx="2225032" cy="182880"/>
+          </a:xfrm>
+          <a:prstGeom prst="rect">
+            <a:avLst/>
+          </a:prstGeom>
+          <a:noFill/>
+        </p:spPr>
+        <p:txBody>
+          <a:bodyPr wrap="square" anchor="t" lIns="0" rIns="0" tIns="0" bIns="0">
+            <a:spAutoFit/>
+          </a:bodyPr>
+          <a:lstStyle/>
+          <a:p>
+            <a:pPr algn="l">
+              <a:lnSpc>
+                <a:spcPct val="100000"/>
+              </a:lnSpc>
+              <a:spcBef>
+                <a:spcPts val="0"/>
+              </a:spcBef>
+              <a:spcAft>
+                <a:spcPts val="0"/>
+              </a:spcAft>
+            </a:pPr>
+            <a:r>
+              <a:rPr sz="1000" b="1" i="0">
+                <a:solidFill>
+                  <a:srgbClr val="F3F1EC"/>
+                </a:solidFill>
+                <a:latin typeface="Calibri"/>
+              </a:rPr>
+              <a:t>España</a:t>
+            </a:r>
+          </a:p>
+        </p:txBody>
+      </p:sp>
+      <p:sp>
+        <p:nvSpPr>
+          <p:cNvPr id="29" name="TextBox 28"/>
+          <p:cNvSpPr txBox="1"/>
+          <p:nvPr/>
+        </p:nvSpPr>
+        <p:spPr>
+          <a:xfrm>
+            <a:off x="3733792" y="5833872"/>
+            <a:ext cx="2225032" cy="182880"/>
+          </a:xfrm>
+          <a:prstGeom prst="rect">
+            <a:avLst/>
+          </a:prstGeom>
+          <a:noFill/>
+        </p:spPr>
+        <p:txBody>
+          <a:bodyPr wrap="square" anchor="t" lIns="0" rIns="0" tIns="0" bIns="0">
+            <a:spAutoFit/>
+          </a:bodyPr>
+          <a:lstStyle/>
+          <a:p>
+            <a:pPr algn="l">
+              <a:lnSpc>
+                <a:spcPct val="100000"/>
+              </a:lnSpc>
+              <a:spcBef>
+                <a:spcPts val="0"/>
+              </a:spcBef>
+              <a:spcAft>
+                <a:spcPts val="0"/>
+              </a:spcAft>
+            </a:pPr>
+            <a:r>
+              <a:rPr sz="900" b="0" i="0">
+                <a:solidFill>
+                  <a:srgbClr val="A9B4C6"/>
+                </a:solidFill>
+                <a:latin typeface="Calibri"/>
+              </a:rPr>
+              <a:t>Regulado (Ley 7/1996)</a:t>
+            </a:r>
+          </a:p>
+        </p:txBody>
+      </p:sp>
+      <p:sp>
+        <p:nvSpPr>
+          <p:cNvPr id="30" name="TextBox 29"/>
+          <p:cNvSpPr txBox="1"/>
+          <p:nvPr/>
+        </p:nvSpPr>
+        <p:spPr>
+          <a:xfrm>
+            <a:off x="6233144" y="5632704"/>
+            <a:ext cx="2225032" cy="182880"/>
+          </a:xfrm>
+          <a:prstGeom prst="rect">
+            <a:avLst/>
+          </a:prstGeom>
+          <a:noFill/>
+        </p:spPr>
+        <p:txBody>
+          <a:bodyPr wrap="square" anchor="t" lIns="0" rIns="0" tIns="0" bIns="0">
+            <a:spAutoFit/>
+          </a:bodyPr>
+          <a:lstStyle/>
+          <a:p>
+            <a:pPr algn="l">
+              <a:lnSpc>
+                <a:spcPct val="100000"/>
+              </a:lnSpc>
+              <a:spcBef>
+                <a:spcPts val="0"/>
+              </a:spcBef>
+              <a:spcAft>
+                <a:spcPts val="0"/>
+              </a:spcAft>
+            </a:pPr>
+            <a:r>
+              <a:rPr sz="1000" b="1" i="0">
+                <a:solidFill>
+                  <a:srgbClr val="F3F1EC"/>
+                </a:solidFill>
+                <a:latin typeface="Calibri"/>
+              </a:rPr>
+              <a:t>Ecuador</a:t>
+            </a:r>
+          </a:p>
+        </p:txBody>
+      </p:sp>
+      <p:sp>
+        <p:nvSpPr>
+          <p:cNvPr id="31" name="TextBox 30"/>
+          <p:cNvSpPr txBox="1"/>
+          <p:nvPr/>
+        </p:nvSpPr>
+        <p:spPr>
+          <a:xfrm>
+            <a:off x="6233144" y="5833872"/>
+            <a:ext cx="2225032" cy="182880"/>
+          </a:xfrm>
+          <a:prstGeom prst="rect">
+            <a:avLst/>
+          </a:prstGeom>
+          <a:noFill/>
+        </p:spPr>
+        <p:txBody>
+          <a:bodyPr wrap="square" anchor="t" lIns="0" rIns="0" tIns="0" bIns="0">
+            <a:spAutoFit/>
+          </a:bodyPr>
+          <a:lstStyle/>
+          <a:p>
+            <a:pPr algn="l">
+              <a:lnSpc>
+                <a:spcPct val="100000"/>
+              </a:lnSpc>
+              <a:spcBef>
+                <a:spcPts val="0"/>
+              </a:spcBef>
+              <a:spcAft>
+                <a:spcPts val="0"/>
+              </a:spcAft>
+            </a:pPr>
+            <a:r>
+              <a:rPr sz="900" b="0" i="0">
+                <a:solidFill>
+                  <a:srgbClr val="A9B4C6"/>
+                </a:solidFill>
+                <a:latin typeface="Calibri"/>
+              </a:rPr>
+              <a:t>Código de Comercio</a:t>
+            </a:r>
+          </a:p>
+        </p:txBody>
+      </p:sp>
+      <p:sp>
+        <p:nvSpPr>
+          <p:cNvPr id="32" name="TextBox 31"/>
+          <p:cNvSpPr txBox="1"/>
+          <p:nvPr/>
+        </p:nvSpPr>
+        <p:spPr>
+          <a:xfrm>
+            <a:off x="8732497" y="5632704"/>
+            <a:ext cx="2225032" cy="182880"/>
+          </a:xfrm>
+          <a:prstGeom prst="rect">
+            <a:avLst/>
+          </a:prstGeom>
+          <a:noFill/>
+        </p:spPr>
+        <p:txBody>
+          <a:bodyPr wrap="square" anchor="t" lIns="0" rIns="0" tIns="0" bIns="0">
+            <a:spAutoFit/>
+          </a:bodyPr>
+          <a:lstStyle/>
+          <a:p>
+            <a:pPr algn="l">
+              <a:lnSpc>
+                <a:spcPct val="100000"/>
+              </a:lnSpc>
+              <a:spcBef>
+                <a:spcPts val="0"/>
+              </a:spcBef>
+              <a:spcAft>
+                <a:spcPts val="0"/>
+              </a:spcAft>
+            </a:pPr>
+            <a:r>
+              <a:rPr sz="1000" b="1" i="0">
+                <a:solidFill>
+                  <a:srgbClr val="F3F1EC"/>
+                </a:solidFill>
+                <a:latin typeface="Calibri"/>
+              </a:rPr>
+              <a:t>Colombia y Perú</a:t>
+            </a:r>
+          </a:p>
+        </p:txBody>
+      </p:sp>
+      <p:sp>
+        <p:nvSpPr>
+          <p:cNvPr id="33" name="TextBox 32"/>
+          <p:cNvSpPr txBox="1"/>
+          <p:nvPr/>
+        </p:nvSpPr>
+        <p:spPr>
+          <a:xfrm>
+            <a:off x="8732497" y="5833872"/>
+            <a:ext cx="2225032" cy="182880"/>
+          </a:xfrm>
+          <a:prstGeom prst="rect">
+            <a:avLst/>
+          </a:prstGeom>
+          <a:noFill/>
+        </p:spPr>
+        <p:txBody>
+          <a:bodyPr wrap="square" anchor="t" lIns="0" rIns="0" tIns="0" bIns="0">
+            <a:spAutoFit/>
+          </a:bodyPr>
+          <a:lstStyle/>
+          <a:p>
+            <a:pPr algn="l">
+              <a:lnSpc>
+                <a:spcPct val="100000"/>
+              </a:lnSpc>
+              <a:spcBef>
+                <a:spcPts val="0"/>
+              </a:spcBef>
+              <a:spcAft>
+                <a:spcPts val="0"/>
+              </a:spcAft>
+            </a:pPr>
+            <a:r>
+              <a:rPr sz="900" b="0" i="0">
+                <a:solidFill>
+                  <a:srgbClr val="A9B4C6"/>
+                </a:solidFill>
+                <a:latin typeface="Calibri"/>
+              </a:rPr>
+              <a:t>Contrato atípico</a:t>
             </a:r>
           </a:p>
         </p:txBody>
@@ -7637,7 +7921,7 @@
         <p:spPr>
           <a:xfrm>
             <a:off x="1124712" y="5230368"/>
-            <a:ext cx="4564364" cy="749808"/>
+            <a:ext cx="1737360" cy="384048"/>
           </a:xfrm>
           <a:prstGeom prst="rect">
             <a:avLst/>
@@ -7652,6 +7936,51 @@
           <a:p>
             <a:pPr algn="l">
               <a:lnSpc>
+                <a:spcPct val="100000"/>
+              </a:lnSpc>
+              <a:spcBef>
+                <a:spcPts val="0"/>
+              </a:spcBef>
+              <a:spcAft>
+                <a:spcPts val="0"/>
+              </a:spcAft>
+            </a:pPr>
+            <a:r>
+              <a:rPr sz="2100" b="0" i="0">
+                <a:solidFill>
+                  <a:srgbClr val="C56C3E"/>
+                </a:solidFill>
+                <a:latin typeface="Georgia"/>
+              </a:rPr>
+              <a:t>20 días</a:t>
+            </a:r>
+          </a:p>
+        </p:txBody>
+      </p:sp>
+      <p:sp>
+        <p:nvSpPr>
+          <p:cNvPr id="41" name="TextBox 40"/>
+          <p:cNvSpPr txBox="1"/>
+          <p:nvPr/>
+        </p:nvSpPr>
+        <p:spPr>
+          <a:xfrm>
+            <a:off x="1124712" y="5632704"/>
+            <a:ext cx="4564364" cy="310896"/>
+          </a:xfrm>
+          <a:prstGeom prst="rect">
+            <a:avLst/>
+          </a:prstGeom>
+          <a:noFill/>
+        </p:spPr>
+        <p:txBody>
+          <a:bodyPr wrap="square" anchor="t" lIns="0" rIns="0" tIns="0" bIns="0">
+            <a:spAutoFit/>
+          </a:bodyPr>
+          <a:lstStyle/>
+          <a:p>
+            <a:pPr algn="l">
+              <a:lnSpc>
                 <a:spcPct val="126000"/>
               </a:lnSpc>
               <a:spcBef>
@@ -7668,14 +7997,14 @@
                 </a:solidFill>
                 <a:latin typeface="Calibri"/>
               </a:rPr>
-              <a:t>El franquiciador debe entregar información sobre su identidad, el sector, las características de la franquicia y la organización de la red al menos 20 días hábiles antes de la firma. Omitirla o deformarla genera responsabilidad aunque el contrato nunca se firme (Conde Gómez, 2020).</a:t>
-            </a:r>
-          </a:p>
-        </p:txBody>
-      </p:sp>
-      <p:sp>
-        <p:nvSpPr>
-          <p:cNvPr id="41" name="Rectangle 40"/>
+              <a:t>hábiles de información previa obligatoria. Omitirla genera responsabilidad aunque no se firme.</a:t>
+            </a:r>
+          </a:p>
+        </p:txBody>
+      </p:sp>
+      <p:sp>
+        <p:nvSpPr>
+          <p:cNvPr id="42" name="Rectangle 41"/>
           <p:cNvSpPr/>
           <p:nvPr/>
         </p:nvSpPr>
@@ -7719,7 +8048,7 @@
       </p:sp>
       <p:sp>
         <p:nvSpPr>
-          <p:cNvPr id="42" name="Rectangle 41"/>
+          <p:cNvPr id="43" name="Rectangle 42"/>
           <p:cNvSpPr/>
           <p:nvPr/>
         </p:nvSpPr>
@@ -7763,7 +8092,7 @@
       </p:sp>
       <p:sp>
         <p:nvSpPr>
-          <p:cNvPr id="43" name="TextBox 42"/>
+          <p:cNvPr id="44" name="TextBox 43"/>
           <p:cNvSpPr txBox="1"/>
           <p:nvPr/>
         </p:nvSpPr>
@@ -7808,14 +8137,14 @@
       </p:sp>
       <p:sp>
         <p:nvSpPr>
-          <p:cNvPr id="44" name="TextBox 43"/>
+          <p:cNvPr id="45" name="TextBox 44"/>
           <p:cNvSpPr txBox="1"/>
           <p:nvPr/>
         </p:nvSpPr>
         <p:spPr>
           <a:xfrm>
-            <a:off x="6502892" y="5230368"/>
-            <a:ext cx="4564364" cy="749808"/>
+            <a:off x="6502892" y="5248656"/>
+            <a:ext cx="4564364" cy="694944"/>
           </a:xfrm>
           <a:prstGeom prst="rect">
             <a:avLst/>
@@ -7830,23 +8159,23 @@
           <a:p>
             <a:pPr algn="l">
               <a:lnSpc>
-                <a:spcPct val="126000"/>
-              </a:lnSpc>
-              <a:spcBef>
-                <a:spcPts val="0"/>
-              </a:spcBef>
-              <a:spcAft>
-                <a:spcPts val="0"/>
-              </a:spcAft>
-            </a:pPr>
-            <a:r>
-              <a:rPr sz="950" b="0" i="0">
+                <a:spcPct val="130000"/>
+              </a:lnSpc>
+              <a:spcBef>
+                <a:spcPts val="0"/>
+              </a:spcBef>
+              <a:spcAft>
+                <a:spcPts val="0"/>
+              </a:spcAft>
+            </a:pPr>
+            <a:r>
+              <a:rPr sz="1200" b="0" i="1">
                 <a:solidFill>
                   <a:srgbClr val="F3F1EC"/>
                 </a:solidFill>
-                <a:latin typeface="Calibri"/>
-              </a:rPr>
-              <a:t>La franquicia combina independencia empresarial con un nivel de control establecido por el titular de la marca. El franquiciado administra su propio negocio, pero no decide sobre todo: opera dentro de un estándar que no le pertenece.</a:t>
+                <a:latin typeface="Georgia"/>
+              </a:rPr>
+              <a:t>Independencia empresarial dentro de un marco de control: el franquiciado administra su negocio, pero no decide sobre todo.</a:t>
             </a:r>
           </a:p>
         </p:txBody>
@@ -8447,7 +8776,7 @@
                 </a:solidFill>
                 <a:latin typeface="Calibri"/>
               </a:rPr>
-              <a:t>Marca y signos distintivos · know-how probado · manuales operativos · asistencia técnica y comercial</a:t>
+              <a:t>Marca y signos distintivos · know-how probado · manuales y asistencia técnica</a:t>
             </a:r>
           </a:p>
         </p:txBody>
@@ -8537,7 +8866,7 @@
                 </a:solidFill>
                 <a:latin typeface="Calibri"/>
               </a:rPr>
-              <a:t>Cobrar canon y regalías · exigir confidencialidad del know-how · actualizar los manuales · exigir la estandarización de la red</a:t>
+              <a:t>Cobrar canon y regalías · exigir confidencialidad · exigir la estandarización de la red</a:t>
             </a:r>
           </a:p>
         </p:txBody>
@@ -8627,7 +8956,7 @@
                 </a:solidFill>
                 <a:latin typeface="Calibri"/>
               </a:rPr>
-              <a:t>Comunicar el know-how · prestar asistencia técnica · entregar la información precontractual · responder ante litigios de propiedad intelectual</a:t>
+              <a:t>Comunicar el know-how · prestar asistencia técnica · informar antes de contratar</a:t>
             </a:r>
           </a:p>
         </p:txBody>
@@ -8897,7 +9226,7 @@
                 </a:solidFill>
                 <a:latin typeface="Calibri"/>
               </a:rPr>
-              <a:t>Canon de entrada e inversión inicial · regalías periódicas · gestión y equipo humano · conocimiento del mercado local</a:t>
+              <a:t>Canon e inversión inicial · regalías periódicas · gestión y conocimiento del mercado local</a:t>
             </a:r>
           </a:p>
         </p:txBody>
@@ -8987,7 +9316,7 @@
                 </a:solidFill>
                 <a:latin typeface="Calibri"/>
               </a:rPr>
-              <a:t>Capacitación y asistencia permanente · manual operativo completo · exclusividad territorial si se pactó · adaptar el producto al mercado local</a:t>
+              <a:t>Capacitación y asistencia · manual operativo completo · exclusividad territorial si se pactó</a:t>
             </a:r>
           </a:p>
         </p:txBody>
@@ -9077,7 +9406,7 @@
                 </a:solidFill>
                 <a:latin typeface="Calibri"/>
               </a:rPr>
-              <a:t>Pagar canon y regalías · mantener la confidencialidad · seguir el manual operativo · permitir auditorías · no competir con la red</a:t>
+              <a:t>Pagar canon y regalías · seguir el manual operativo · no competir con la red</a:t>
             </a:r>
           </a:p>
         </p:txBody>
@@ -9090,8 +9419,8 @@
         </p:nvSpPr>
         <p:spPr>
           <a:xfrm>
-            <a:off x="868680" y="5138928"/>
-            <a:ext cx="10454609" cy="475488"/>
+            <a:off x="868680" y="5175504"/>
+            <a:ext cx="10454609" cy="402336"/>
           </a:xfrm>
           <a:prstGeom prst="rect">
             <a:avLst/>
@@ -9134,8 +9463,8 @@
         </p:nvSpPr>
         <p:spPr>
           <a:xfrm>
-            <a:off x="1179576" y="5212080"/>
-            <a:ext cx="9832817" cy="365760"/>
+            <a:off x="1179576" y="5175504"/>
+            <a:ext cx="9832817" cy="402336"/>
           </a:xfrm>
           <a:prstGeom prst="rect">
             <a:avLst/>
@@ -9143,14 +9472,14 @@
           <a:noFill/>
         </p:spPr>
         <p:txBody>
-          <a:bodyPr wrap="square" anchor="t" lIns="0" rIns="0" tIns="0" bIns="0">
+          <a:bodyPr wrap="square" anchor="ctr" lIns="0" rIns="0" tIns="0" bIns="0">
             <a:spAutoFit/>
           </a:bodyPr>
           <a:lstStyle/>
           <a:p>
             <a:pPr algn="l">
               <a:lnSpc>
-                <a:spcPct val="126000"/>
+                <a:spcPct val="120000"/>
               </a:lnSpc>
               <a:spcBef>
                 <a:spcPts val="0"/>
@@ -9166,7 +9495,7 @@
                 </a:solidFill>
                 <a:latin typeface="Calibri"/>
               </a:rPr>
-              <a:t>Y un tercero cuando la red se internacionaliza.  </a:t>
+              <a:t>Y un tercero cuando la red se internacionaliza:  </a:t>
             </a:r>
             <a:r>
               <a:rPr sz="950" b="0" i="0">
@@ -9175,7 +9504,7 @@
                 </a:solidFill>
                 <a:latin typeface="Calibri"/>
               </a:rPr>
-              <a:t>Aparece el subfranquiciante o máster franquiciado, que sin ser titular de la marca asume frente a terceros las funciones propias de un franquiciador (Speicher Mendiola, 2024; Conde Gómez, 2020).</a:t>
+              <a:t>el subfranquiciante o máster franquiciado.</a:t>
             </a:r>
           </a:p>
         </p:txBody>
@@ -9188,8 +9517,8 @@
         </p:nvSpPr>
         <p:spPr>
           <a:xfrm>
-            <a:off x="868680" y="5669280"/>
-            <a:ext cx="10454609" cy="457200"/>
+            <a:off x="868680" y="5632704"/>
+            <a:ext cx="10454609" cy="420624"/>
           </a:xfrm>
           <a:prstGeom prst="rect">
             <a:avLst/>
@@ -9232,8 +9561,8 @@
         </p:nvSpPr>
         <p:spPr>
           <a:xfrm>
-            <a:off x="1179576" y="5724144"/>
-            <a:ext cx="9832817" cy="365760"/>
+            <a:off x="1179576" y="5632704"/>
+            <a:ext cx="9832817" cy="420624"/>
           </a:xfrm>
           <a:prstGeom prst="rect">
             <a:avLst/>
@@ -9241,14 +9570,14 @@
           <a:noFill/>
         </p:spPr>
         <p:txBody>
-          <a:bodyPr wrap="square" anchor="t" lIns="0" rIns="0" tIns="0" bIns="0">
+          <a:bodyPr wrap="square" anchor="ctr" lIns="0" rIns="0" tIns="0" bIns="0">
             <a:spAutoFit/>
           </a:bodyPr>
           <a:lstStyle/>
           <a:p>
             <a:pPr algn="l">
               <a:lnSpc>
-                <a:spcPct val="126000"/>
+                <a:spcPct val="120000"/>
               </a:lnSpc>
               <a:spcBef>
                 <a:spcPts val="0"/>
@@ -9264,7 +9593,7 @@
                 </a:solidFill>
                 <a:latin typeface="Calibri"/>
               </a:rPr>
-              <a:t>Independencia declarada, pero no absoluta.  </a:t>
+              <a:t>Independientes por ley (art. 1520 CCyC),  </a:t>
             </a:r>
             <a:r>
               <a:rPr sz="950" b="0" i="0">
@@ -9273,7 +9602,7 @@
                 </a:solidFill>
                 <a:latin typeface="Calibri"/>
               </a:rPr>
-              <a:t>Argentina afirma que las partes son independientes (art. 1520 CCyC) y el proyecto colombiano descarta la solidaridad pasiva salvo pacto expreso. Aun así, la jurisprudencia española la extiende al franquiciador cuando el daño deriva de sus instrucciones concretas.</a:t>
+              <a:t>aunque la responsabilidad alcanza al franquiciador cuando el daño deriva de sus instrucciones concretas.</a:t>
             </a:r>
           </a:p>
         </p:txBody>
@@ -9774,11 +10103,11 @@
                 <a:spcPts val="0"/>
               </a:spcBef>
               <a:spcAft>
-                <a:spcPts val="1100"/>
-              </a:spcAft>
-            </a:pPr>
-            <a:r>
-              <a:rPr sz="950" b="1" i="0">
+                <a:spcPts val="800"/>
+              </a:spcAft>
+            </a:pPr>
+            <a:r>
+              <a:rPr sz="1050" b="1" i="0">
                 <a:solidFill>
                   <a:srgbClr val="C56C3E"/>
                 </a:solidFill>
@@ -9787,7 +10116,7 @@
               <a:t>1. </a:t>
             </a:r>
             <a:r>
-              <a:rPr sz="950" b="1" i="0">
+              <a:rPr sz="1050" b="1" i="0">
                 <a:solidFill>
                   <a:srgbClr val="1B2A41"/>
                 </a:solidFill>
@@ -9796,13 +10125,13 @@
               <a:t>Reconocimiento de marca: </a:t>
             </a:r>
             <a:r>
-              <a:rPr sz="950" b="0" i="0">
+              <a:rPr sz="1050" b="0" i="0">
                 <a:solidFill>
                   <a:srgbClr val="445570"/>
                 </a:solidFill>
                 <a:latin typeface="Calibri"/>
               </a:rPr>
-              <a:t>se arranca con una marca posicionada: capta clientes antes y gana reputación más rápido.</a:t>
+              <a:t>se parte de una marca ya posicionada en el mercado.</a:t>
             </a:r>
           </a:p>
           <a:p>
@@ -9814,11 +10143,11 @@
                 <a:spcPts val="0"/>
               </a:spcBef>
               <a:spcAft>
-                <a:spcPts val="1100"/>
-              </a:spcAft>
-            </a:pPr>
-            <a:r>
-              <a:rPr sz="950" b="1" i="0">
+                <a:spcPts val="800"/>
+              </a:spcAft>
+            </a:pPr>
+            <a:r>
+              <a:rPr sz="1050" b="1" i="0">
                 <a:solidFill>
                   <a:srgbClr val="C56C3E"/>
                 </a:solidFill>
@@ -9827,22 +10156,22 @@
               <a:t>2. </a:t>
             </a:r>
             <a:r>
-              <a:rPr sz="950" b="1" i="0">
+              <a:rPr sz="1050" b="1" i="0">
                 <a:solidFill>
                   <a:srgbClr val="1B2A41"/>
                 </a:solidFill>
                 <a:latin typeface="Calibri"/>
               </a:rPr>
-              <a:t>Modelo de negocio validado: </a:t>
-            </a:r>
-            <a:r>
-              <a:rPr sz="950" b="0" i="0">
+              <a:t>Modelo validado: </a:t>
+            </a:r>
+            <a:r>
+              <a:rPr sz="1050" b="0" i="0">
                 <a:solidFill>
                   <a:srgbClr val="445570"/>
                 </a:solidFill>
                 <a:latin typeface="Calibri"/>
               </a:rPr>
-              <a:t>se accede a un negocio ya probado y se reduce la incertidumbre de crear una marca desde cero.</a:t>
+              <a:t>negocio ya probado, sin la incertidumbre de empezar de cero.</a:t>
             </a:r>
           </a:p>
           <a:p>
@@ -9854,11 +10183,11 @@
                 <a:spcPts val="0"/>
               </a:spcBef>
               <a:spcAft>
-                <a:spcPts val="1100"/>
-              </a:spcAft>
-            </a:pPr>
-            <a:r>
-              <a:rPr sz="950" b="1" i="0">
+                <a:spcPts val="800"/>
+              </a:spcAft>
+            </a:pPr>
+            <a:r>
+              <a:rPr sz="1050" b="1" i="0">
                 <a:solidFill>
                   <a:srgbClr val="C56C3E"/>
                 </a:solidFill>
@@ -9867,22 +10196,22 @@
               <a:t>3. </a:t>
             </a:r>
             <a:r>
-              <a:rPr sz="950" b="1" i="0">
+              <a:rPr sz="1050" b="1" i="0">
                 <a:solidFill>
                   <a:srgbClr val="1B2A41"/>
                 </a:solidFill>
                 <a:latin typeface="Calibri"/>
               </a:rPr>
-              <a:t>Menor riesgo empresarial: </a:t>
-            </a:r>
-            <a:r>
-              <a:rPr sz="950" b="0" i="0">
+              <a:t>Menor riesgo: </a:t>
+            </a:r>
+            <a:r>
+              <a:rPr sz="1050" b="0" i="0">
                 <a:solidFill>
                   <a:srgbClr val="445570"/>
                 </a:solidFill>
                 <a:latin typeface="Calibri"/>
               </a:rPr>
-              <a:t>registra tasas de supervivencia superiores a las de los negocios independientes.</a:t>
+              <a:t>más supervivencia que un negocio independiente equivalente.</a:t>
             </a:r>
           </a:p>
           <a:p>
@@ -9894,11 +10223,11 @@
                 <a:spcPts val="0"/>
               </a:spcBef>
               <a:spcAft>
-                <a:spcPts val="1100"/>
-              </a:spcAft>
-            </a:pPr>
-            <a:r>
-              <a:rPr sz="950" b="1" i="0">
+                <a:spcPts val="800"/>
+              </a:spcAft>
+            </a:pPr>
+            <a:r>
+              <a:rPr sz="1050" b="1" i="0">
                 <a:solidFill>
                   <a:srgbClr val="C56C3E"/>
                 </a:solidFill>
@@ -9907,7 +10236,7 @@
               <a:t>4. </a:t>
             </a:r>
             <a:r>
-              <a:rPr sz="950" b="1" i="0">
+              <a:rPr sz="1050" b="1" i="0">
                 <a:solidFill>
                   <a:srgbClr val="1B2A41"/>
                 </a:solidFill>
@@ -9916,13 +10245,13 @@
               <a:t>Capacitación y asistencia: </a:t>
             </a:r>
             <a:r>
-              <a:rPr sz="950" b="0" i="0">
+              <a:rPr sz="1050" b="0" i="0">
                 <a:solidFill>
                   <a:srgbClr val="445570"/>
                 </a:solidFill>
                 <a:latin typeface="Calibri"/>
               </a:rPr>
-              <a:t>formación técnica inicial y acompañamiento continuo en marketing, operaciones y gestión.</a:t>
+              <a:t>formación inicial y acompañamiento continuo de la marca.</a:t>
             </a:r>
           </a:p>
           <a:p>
@@ -9934,11 +10263,11 @@
                 <a:spcPts val="0"/>
               </a:spcBef>
               <a:spcAft>
-                <a:spcPts val="1100"/>
-              </a:spcAft>
-            </a:pPr>
-            <a:r>
-              <a:rPr sz="950" b="1" i="0">
+                <a:spcPts val="800"/>
+              </a:spcAft>
+            </a:pPr>
+            <a:r>
+              <a:rPr sz="1050" b="1" i="0">
                 <a:solidFill>
                   <a:srgbClr val="C56C3E"/>
                 </a:solidFill>
@@ -9947,7 +10276,7 @@
               <a:t>5. </a:t>
             </a:r>
             <a:r>
-              <a:rPr sz="950" b="1" i="0">
+              <a:rPr sz="1050" b="1" i="0">
                 <a:solidFill>
                   <a:srgbClr val="1B2A41"/>
                 </a:solidFill>
@@ -9956,13 +10285,13 @@
               <a:t>Apoyo en marketing: </a:t>
             </a:r>
             <a:r>
-              <a:rPr sz="950" b="0" i="0">
+              <a:rPr sz="1050" b="0" i="0">
                 <a:solidFill>
                   <a:srgbClr val="445570"/>
                 </a:solidFill>
                 <a:latin typeface="Calibri"/>
               </a:rPr>
-              <a:t>las campañas y las redes sociales se diseñan y coordinan desde la marca.</a:t>
+              <a:t>las campañas y las redes se coordinan desde la marca.</a:t>
             </a:r>
           </a:p>
           <a:p>
@@ -9974,11 +10303,11 @@
                 <a:spcPts val="0"/>
               </a:spcBef>
               <a:spcAft>
-                <a:spcPts val="1100"/>
-              </a:spcAft>
-            </a:pPr>
-            <a:r>
-              <a:rPr sz="950" b="1" i="0">
+                <a:spcPts val="800"/>
+              </a:spcAft>
+            </a:pPr>
+            <a:r>
+              <a:rPr sz="1050" b="1" i="0">
                 <a:solidFill>
                   <a:srgbClr val="C56C3E"/>
                 </a:solidFill>
@@ -9987,7 +10316,7 @@
               <a:t>6. </a:t>
             </a:r>
             <a:r>
-              <a:rPr sz="950" b="1" i="0">
+              <a:rPr sz="1050" b="1" i="0">
                 <a:solidFill>
                   <a:srgbClr val="1B2A41"/>
                 </a:solidFill>
@@ -9996,13 +10325,13 @@
               <a:t>Economías de escala: </a:t>
             </a:r>
             <a:r>
-              <a:rPr sz="950" b="0" i="0">
+              <a:rPr sz="1050" b="0" i="0">
                 <a:solidFill>
                   <a:srgbClr val="445570"/>
                 </a:solidFill>
                 <a:latin typeface="Calibri"/>
               </a:rPr>
-              <a:t>la red negocia como bloque: mejores condiciones y menores costos de adquisición.</a:t>
+              <a:t>la red negocia como bloque y reduce costos de compra.</a:t>
             </a:r>
           </a:p>
         </p:txBody>
@@ -10172,11 +10501,11 @@
                 <a:spcPts val="0"/>
               </a:spcBef>
               <a:spcAft>
-                <a:spcPts val="1100"/>
-              </a:spcAft>
-            </a:pPr>
-            <a:r>
-              <a:rPr sz="950" b="1" i="0">
+                <a:spcPts val="800"/>
+              </a:spcAft>
+            </a:pPr>
+            <a:r>
+              <a:rPr sz="1050" b="1" i="0">
                 <a:solidFill>
                   <a:srgbClr val="C56C3E"/>
                 </a:solidFill>
@@ -10185,7 +10514,7 @@
               <a:t>1. </a:t>
             </a:r>
             <a:r>
-              <a:rPr sz="950" b="1" i="0">
+              <a:rPr sz="1050" b="1" i="0">
                 <a:solidFill>
                   <a:srgbClr val="1B2A41"/>
                 </a:solidFill>
@@ -10194,13 +10523,13 @@
               <a:t>Costos elevados: </a:t>
             </a:r>
             <a:r>
-              <a:rPr sz="950" b="0" i="0">
+              <a:rPr sz="1050" b="0" i="0">
                 <a:solidFill>
                   <a:srgbClr val="445570"/>
                 </a:solidFill>
                 <a:latin typeface="Calibri"/>
               </a:rPr>
-              <a:t>inversión inicial alta más pagos continuos por regalías y publicidad.</a:t>
+              <a:t>inversión inicial alta más regalías y aportes de publicidad.</a:t>
             </a:r>
           </a:p>
           <a:p>
@@ -10212,11 +10541,11 @@
                 <a:spcPts val="0"/>
               </a:spcBef>
               <a:spcAft>
-                <a:spcPts val="1100"/>
-              </a:spcAft>
-            </a:pPr>
-            <a:r>
-              <a:rPr sz="950" b="1" i="0">
+                <a:spcPts val="800"/>
+              </a:spcAft>
+            </a:pPr>
+            <a:r>
+              <a:rPr sz="1050" b="1" i="0">
                 <a:solidFill>
                   <a:srgbClr val="C56C3E"/>
                 </a:solidFill>
@@ -10225,22 +10554,22 @@
               <a:t>2. </a:t>
             </a:r>
             <a:r>
-              <a:rPr sz="950" b="1" i="0">
+              <a:rPr sz="1050" b="1" i="0">
                 <a:solidFill>
                   <a:srgbClr val="1B2A41"/>
                 </a:solidFill>
                 <a:latin typeface="Calibri"/>
               </a:rPr>
-              <a:t>Limitación de la autonomía: </a:t>
-            </a:r>
-            <a:r>
-              <a:rPr sz="950" b="0" i="0">
+              <a:t>Autonomía limitada: </a:t>
+            </a:r>
+            <a:r>
+              <a:rPr sz="1050" b="0" i="0">
                 <a:solidFill>
                   <a:srgbClr val="445570"/>
                 </a:solidFill>
                 <a:latin typeface="Calibri"/>
               </a:rPr>
-              <a:t>debe seguir con rigor las políticas, estándares y procedimientos del franquiciador.</a:t>
+              <a:t>manda el estándar del franquiciador, no el criterio propio.</a:t>
             </a:r>
           </a:p>
           <a:p>
@@ -10252,11 +10581,11 @@
                 <a:spcPts val="0"/>
               </a:spcBef>
               <a:spcAft>
-                <a:spcPts val="1100"/>
-              </a:spcAft>
-            </a:pPr>
-            <a:r>
-              <a:rPr sz="950" b="1" i="0">
+                <a:spcPts val="800"/>
+              </a:spcAft>
+            </a:pPr>
+            <a:r>
+              <a:rPr sz="1050" b="1" i="0">
                 <a:solidFill>
                   <a:srgbClr val="C56C3E"/>
                 </a:solidFill>
@@ -10265,22 +10594,22 @@
               <a:t>3. </a:t>
             </a:r>
             <a:r>
-              <a:rPr sz="950" b="1" i="0">
+              <a:rPr sz="1050" b="1" i="0">
                 <a:solidFill>
                   <a:srgbClr val="1B2A41"/>
                 </a:solidFill>
                 <a:latin typeface="Calibri"/>
               </a:rPr>
-              <a:t>Regalías al margen del resultado: </a:t>
-            </a:r>
-            <a:r>
-              <a:rPr sz="950" b="0" i="0">
+              <a:t>Regalías fijas: </a:t>
+            </a:r>
+            <a:r>
+              <a:rPr sz="1050" b="0" i="0">
                 <a:solidFill>
                   <a:srgbClr val="445570"/>
                 </a:solidFill>
                 <a:latin typeface="Calibri"/>
               </a:rPr>
-              <a:t>se pagan aunque el negocio no genere las ganancias esperadas.</a:t>
+              <a:t>se pagan aunque el negocio no dé las ganancias esperadas.</a:t>
             </a:r>
           </a:p>
           <a:p>
@@ -10292,11 +10621,11 @@
                 <a:spcPts val="0"/>
               </a:spcBef>
               <a:spcAft>
-                <a:spcPts val="1100"/>
-              </a:spcAft>
-            </a:pPr>
-            <a:r>
-              <a:rPr sz="950" b="1" i="0">
+                <a:spcPts val="800"/>
+              </a:spcAft>
+            </a:pPr>
+            <a:r>
+              <a:rPr sz="1050" b="1" i="0">
                 <a:solidFill>
                   <a:srgbClr val="C56C3E"/>
                 </a:solidFill>
@@ -10305,7 +10634,7 @@
               <a:t>4. </a:t>
             </a:r>
             <a:r>
-              <a:rPr sz="950" b="1" i="0">
+              <a:rPr sz="1050" b="1" i="0">
                 <a:solidFill>
                   <a:srgbClr val="1B2A41"/>
                 </a:solidFill>
@@ -10314,13 +10643,13 @@
               <a:t>Conflictos entre las partes: </a:t>
             </a:r>
             <a:r>
-              <a:rPr sz="950" b="0" i="0">
+              <a:rPr sz="1050" b="0" i="0">
                 <a:solidFill>
                   <a:srgbClr val="445570"/>
                 </a:solidFill>
                 <a:latin typeface="Calibri"/>
               </a:rPr>
-              <a:t>diferencias sobre estrategias, proveedores autorizados o condiciones económicas.</a:t>
+              <a:t>por estrategias, proveedores o condiciones económicas.</a:t>
             </a:r>
           </a:p>
           <a:p>
@@ -10332,11 +10661,11 @@
                 <a:spcPts val="0"/>
               </a:spcBef>
               <a:spcAft>
-                <a:spcPts val="1100"/>
-              </a:spcAft>
-            </a:pPr>
-            <a:r>
-              <a:rPr sz="950" b="1" i="0">
+                <a:spcPts val="800"/>
+              </a:spcAft>
+            </a:pPr>
+            <a:r>
+              <a:rPr sz="1050" b="1" i="0">
                 <a:solidFill>
                   <a:srgbClr val="C56C3E"/>
                 </a:solidFill>
@@ -10345,7 +10674,7 @@
               <a:t>5. </a:t>
             </a:r>
             <a:r>
-              <a:rPr sz="950" b="1" i="0">
+              <a:rPr sz="1050" b="1" i="0">
                 <a:solidFill>
                   <a:srgbClr val="1B2A41"/>
                 </a:solidFill>
@@ -10354,13 +10683,13 @@
               <a:t>Cláusulas estrictas: </a:t>
             </a:r>
             <a:r>
-              <a:rPr sz="950" b="0" i="0">
+              <a:rPr sz="1050" b="0" i="0">
                 <a:solidFill>
                   <a:srgbClr val="445570"/>
                 </a:solidFill>
                 <a:latin typeface="Calibri"/>
               </a:rPr>
-              <a:t>exclusividad, duración, renovación y restricciones que limitan la flexibilidad.</a:t>
+              <a:t>exclusividad, duración, renovación y límites operativos.</a:t>
             </a:r>
           </a:p>
           <a:p>
@@ -10372,11 +10701,11 @@
                 <a:spcPts val="0"/>
               </a:spcBef>
               <a:spcAft>
-                <a:spcPts val="1100"/>
-              </a:spcAft>
-            </a:pPr>
-            <a:r>
-              <a:rPr sz="950" b="1" i="0">
+                <a:spcPts val="800"/>
+              </a:spcAft>
+            </a:pPr>
+            <a:r>
+              <a:rPr sz="1050" b="1" i="0">
                 <a:solidFill>
                   <a:srgbClr val="C56C3E"/>
                 </a:solidFill>
@@ -10385,22 +10714,22 @@
               <a:t>6. </a:t>
             </a:r>
             <a:r>
-              <a:rPr sz="950" b="1" i="0">
+              <a:rPr sz="1050" b="1" i="0">
                 <a:solidFill>
                   <a:srgbClr val="1B2A41"/>
                 </a:solidFill>
                 <a:latin typeface="Calibri"/>
               </a:rPr>
-              <a:t>Dependencia de la reputación ajena: </a:t>
-            </a:r>
-            <a:r>
-              <a:rPr sz="950" b="0" i="0">
+              <a:t>Reputación ajena: </a:t>
+            </a:r>
+            <a:r>
+              <a:rPr sz="1050" b="0" i="0">
                 <a:solidFill>
                   <a:srgbClr val="445570"/>
                 </a:solidFill>
                 <a:latin typeface="Calibri"/>
               </a:rPr>
-              <a:t>un golpe a la imagen del franquiciador repercute sobre toda la red.</a:t>
+              <a:t>un golpe a la imagen de la marca afecta a toda la red.</a:t>
             </a:r>
           </a:p>
         </p:txBody>
@@ -10999,7 +11328,7 @@
                 </a:solidFill>
                 <a:latin typeface="Calibri"/>
               </a:rPr>
-              <a:t>Veinte años en la organización. Ha sido gerente de tiendas minoristas, gerente de operaciones y director de retail. Hoy supervisa la operación integral del grupo, que incluye más de 40 franquicias.</a:t>
+              <a:t>Veinte años en la organización. Pasó por gerencia de tiendas, operaciones y dirección de retail.</a:t>
             </a:r>
           </a:p>
         </p:txBody>

</xml_diff>